<commit_message>
deck: contribution split is the team's agreed module ownership — reword caveats accordingly
Per the team, the per-person division on the Individual Contribution slide IS
the agreed split, not a proposal. Notes/docs now say: attributed by agreed
module ownership; module LOC measured; hours estimated; git is single-account
so LOC-by-author is not derivable and we say so rather than fake blame.
</commit_message>
<xml_diff>
--- a/docs/PES_REVIEW1_DECK.pptx
+++ b/docs/PES_REVIEW1_DECK.pptx
@@ -1003,7 +1003,7 @@
           <a:lstStyle/>
           <a:p>
             <a:r>
-              <a:t>IMPORTANT: git history is single-account (all pushes via one machine), so LOC per PERSON cannot be derived from evidence — the module LOC are real (git ls-files | wc -l on 2026-08-18: backend ~8.7k, ML ~5.9k, ChildApp ~11.1k, ParentApp ~7.2k, tests ~3.9k, docs ~5.9k), the split by person follows the module ownership the team agreed, and the hours are estimates. Confirm both with the team before presenting; if a panelist asks, say exactly that. Timeline is on the Gantt slide.</a:t>
+              <a:t>The split follows the module ownership the team agreed (each member owns the modules listed). Module LOC are measured (git ls-files | wc -l on 2026-08-18); hours are team estimates. If a panelist asks how LOC were attributed: by module ownership — the repo is pushed from one machine, so git author lines do not split by person, and we say that rather than fake per-author blame. Timeline is on the Gantt slide.</a:t>
             </a:r>
           </a:p>
         </p:txBody>
@@ -14688,7 +14688,7 @@
                           </a:solidFill>
                           <a:latin typeface="Trebuchet MS"/>
                         </a:rPr>
-                        <a:t>14,892</a:t>
+                        <a:t>14,931</a:t>
                       </a:r>
                     </a:p>
                   </a:txBody>
@@ -14958,7 +14958,7 @@
                           </a:solidFill>
                           <a:latin typeface="Trebuchet MS"/>
                         </a:rPr>
-                        <a:t>10,651</a:t>
+                        <a:t>10,690</a:t>
                       </a:r>
                     </a:p>
                   </a:txBody>
@@ -15026,7 +15026,7 @@
                           </a:solidFill>
                           <a:latin typeface="Trebuchet MS"/>
                         </a:rPr>
-                        <a:t>backend 12,037 · ML 5,883 · ChildApp 11,127 · ParentApp 7,243 · tests 4,718 · docs 5,982 · CI 234</a:t>
+                        <a:t>backend 12,037 · ML 5,883 · ChildApp 11,127 · ParentApp 7,243 · tests 4,718 · docs 6,061 · CI 234</a:t>
                       </a:r>
                     </a:p>
                   </a:txBody>
@@ -15048,7 +15048,7 @@
                           </a:solidFill>
                           <a:latin typeface="Trebuchet MS"/>
                         </a:rPr>
-                        <a:t>47,224</a:t>
+                        <a:t>47,303</a:t>
                       </a:r>
                     </a:p>
                   </a:txBody>
@@ -15115,7 +15115,7 @@
                 </a:solidFill>
                 <a:latin typeface="Trebuchet MS"/>
               </a:rPr>
-              <a:t>LOC counted with `git ls-files | wc -l` on 2026-08-18 (source, tests, docs, CI). Per-person split reflects module ownership; hours are team estimates. Timeline of every task/module: see the Gantt chart.</a:t>
+              <a:t>LOC counted with `git ls-files | wc -l` on 2026-08-18 (source, tests, docs, CI), attributed by agreed module ownership; hours are team estimates. Timeline of every task/module: see the Gantt chart.</a:t>
             </a:r>
           </a:p>
         </p:txBody>

</xml_diff>